<commit_message>
Update AI 五層次 descriptions per forTeacher rewrite
forTeacher.org reframed Lv.3–5 around who plans the steps vs. who
operates the computer:
- Lv.3 (initial assistant): AI plans, AI operates
- Lv.4 (advanced):           you plan, AI operates
- Lv.5 (dedicated):          AI plans, AI operates (autonomous)

Mirror the new wording and tool list (Claude Code/CLIo for Lv.4) into
slides.html and generate_slides.py, then rebuild the pptx so all three
artifacts agree.

Co-Authored-By: Claude Opus 4.7 (1M context) <noreply@anthropic.com>
</commit_message>
<xml_diff>
--- a/和AI作朋友-工作坊簡報.pptx
+++ b/和AI作朋友-工作坊簡報.pptx
@@ -18673,7 +18673,7 @@
               </a:defRPr>
             </a:pPr>
             <a:r>
-              <a:t>AI 嵌進你的工具裡</a:t>
+              <a:t>AI 直接嵌在你的工具裡</a:t>
             </a:r>
           </a:p>
         </p:txBody>
@@ -18876,7 +18876,7 @@
               </a:defRPr>
             </a:pPr>
             <a:r>
-              <a:t>AI Agent</a:t>
+              <a:t>AI Agent（初級助理）</a:t>
             </a:r>
           </a:p>
         </p:txBody>
@@ -19196,7 +19196,7 @@
               </a:defRPr>
             </a:pPr>
             <a:r>
-              <a:t>它記得你的偏好</a:t>
+              <a:t>你規劃步驟，AI 幫你操作電腦</a:t>
             </a:r>
           </a:p>
         </p:txBody>
@@ -19235,7 +19235,7 @@
               </a:defRPr>
             </a:pPr>
             <a:r>
-              <a:t>Skills、MCP</a:t>
+              <a:t>Claude Code / CLIo</a:t>
             </a:r>
           </a:p>
         </p:txBody>
@@ -19438,7 +19438,7 @@
               </a:defRPr>
             </a:pPr>
             <a:r>
-              <a:t>自動完成、主動建議</a:t>
+              <a:t>AI 幫你規劃步驟，幫你操作電腦</a:t>
             </a:r>
           </a:p>
         </p:txBody>

</xml_diff>

<commit_message>
Embed actual QR codes on the pptx title slide
The original title_slide() drew a card with literal "QR" text instead
of inserting the image — the placeholder shipped because no one ever
opened slide 1. Pull in img/qr-slides.png and img/qr-index.png on a
white card so they can actually be scanned.

Co-Authored-By: Claude Opus 4.7 (1M context) <noreply@anthropic.com>
</commit_message>
<xml_diff>
--- a/和AI作朋友-工作坊簡報.pptx
+++ b/和AI作朋友-工作坊簡報.pptx
@@ -6876,7 +6876,7 @@
             <a:avLst/>
           </a:prstGeom>
           <a:solidFill>
-            <a:srgbClr val="222B45"/>
+            <a:srgbClr val="FFFFFF"/>
           </a:solidFill>
           <a:ln>
             <a:noFill/>
@@ -6904,45 +6904,30 @@
           </a:p>
         </p:txBody>
       </p:sp>
-      <p:sp>
-        <p:nvSpPr>
-          <p:cNvPr id="7" name="TextBox 6"/>
-          <p:cNvSpPr txBox="1"/>
-          <p:nvPr/>
-        </p:nvSpPr>
-        <p:spPr>
-          <a:xfrm>
-            <a:off x="3200400" y="5486400"/>
-            <a:ext cx="1371600" cy="365760"/>
-          </a:xfrm>
-          <a:prstGeom prst="rect">
-            <a:avLst/>
-          </a:prstGeom>
-          <a:noFill/>
-        </p:spPr>
-        <p:txBody>
-          <a:bodyPr wrap="square" lIns="0" rIns="0" tIns="0" bIns="0">
-            <a:spAutoFit/>
-          </a:bodyPr>
-          <a:lstStyle/>
-          <a:p>
-            <a:pPr algn="ctr">
-              <a:lnSpc>
-                <a:spcPct val="140000"/>
-              </a:lnSpc>
-              <a:defRPr sz="1800" b="0">
-                <a:solidFill>
-                  <a:srgbClr val="9999AA"/>
-                </a:solidFill>
-                <a:latin typeface="Helvetica Neue"/>
-              </a:defRPr>
-            </a:pPr>
-            <a:r>
-              <a:t>QR</a:t>
-            </a:r>
-          </a:p>
-        </p:txBody>
-      </p:sp>
+      <p:pic>
+        <p:nvPicPr>
+          <p:cNvPr id="7" name="Picture 6" descr="qr-slides.png"/>
+          <p:cNvPicPr>
+            <a:picLocks noChangeAspect="1"/>
+          </p:cNvPicPr>
+          <p:nvPr/>
+        </p:nvPicPr>
+        <p:blipFill>
+          <a:blip r:embed="rId2"/>
+          <a:stretch>
+            <a:fillRect/>
+          </a:stretch>
+        </p:blipFill>
+        <p:spPr>
+          <a:xfrm>
+            <a:off x="3246120" y="4983480"/>
+            <a:ext cx="1280160" cy="1280160"/>
+          </a:xfrm>
+          <a:prstGeom prst="rect">
+            <a:avLst/>
+          </a:prstGeom>
+        </p:spPr>
+      </p:pic>
       <p:sp>
         <p:nvSpPr>
           <p:cNvPr id="8" name="TextBox 7"/>
@@ -7036,7 +7021,7 @@
             <a:avLst/>
           </a:prstGeom>
           <a:solidFill>
-            <a:srgbClr val="222B45"/>
+            <a:srgbClr val="FFFFFF"/>
           </a:solidFill>
           <a:ln>
             <a:noFill/>
@@ -7064,45 +7049,30 @@
           </a:p>
         </p:txBody>
       </p:sp>
-      <p:sp>
-        <p:nvSpPr>
-          <p:cNvPr id="11" name="TextBox 10"/>
-          <p:cNvSpPr txBox="1"/>
-          <p:nvPr/>
-        </p:nvSpPr>
-        <p:spPr>
-          <a:xfrm>
-            <a:off x="7132320" y="5486400"/>
-            <a:ext cx="1371600" cy="365760"/>
-          </a:xfrm>
-          <a:prstGeom prst="rect">
-            <a:avLst/>
-          </a:prstGeom>
-          <a:noFill/>
-        </p:spPr>
-        <p:txBody>
-          <a:bodyPr wrap="square" lIns="0" rIns="0" tIns="0" bIns="0">
-            <a:spAutoFit/>
-          </a:bodyPr>
-          <a:lstStyle/>
-          <a:p>
-            <a:pPr algn="ctr">
-              <a:lnSpc>
-                <a:spcPct val="140000"/>
-              </a:lnSpc>
-              <a:defRPr sz="1800" b="0">
-                <a:solidFill>
-                  <a:srgbClr val="9999AA"/>
-                </a:solidFill>
-                <a:latin typeface="Helvetica Neue"/>
-              </a:defRPr>
-            </a:pPr>
-            <a:r>
-              <a:t>QR</a:t>
-            </a:r>
-          </a:p>
-        </p:txBody>
-      </p:sp>
+      <p:pic>
+        <p:nvPicPr>
+          <p:cNvPr id="11" name="Picture 10" descr="qr-index.png"/>
+          <p:cNvPicPr>
+            <a:picLocks noChangeAspect="1"/>
+          </p:cNvPicPr>
+          <p:nvPr/>
+        </p:nvPicPr>
+        <p:blipFill>
+          <a:blip r:embed="rId3"/>
+          <a:stretch>
+            <a:fillRect/>
+          </a:stretch>
+        </p:blipFill>
+        <p:spPr>
+          <a:xfrm>
+            <a:off x="7178040" y="4983480"/>
+            <a:ext cx="1280160" cy="1280160"/>
+          </a:xfrm>
+          <a:prstGeom prst="rect">
+            <a:avLst/>
+          </a:prstGeom>
+        </p:spPr>
+      </p:pic>
       <p:sp>
         <p:nvSpPr>
           <p:cNvPr id="12" name="TextBox 11"/>

</xml_diff>